<commit_message>
Use the report's system architecture diagram in the presentation
Co-authored-by: Shubh Jasuja <shubhjasuja321@gmail.com>
Co-authored-by: Shubham Rajurkar <rajurkars126@gmail.com>
Co-authored-by: Varad Mhetar <mhetarvarad@gmail.com>
Co-authored-by: Raj Nikam <rajnikam314@gmail.com>
</commit_message>
<xml_diff>
--- a/docs/report/DPDP_Project_Presentation.pptx
+++ b/docs/report/DPDP_Project_Presentation.pptx
@@ -14285,7 +14285,7 @@
         <p:spPr>
           <a:xfrm>
             <a:off x="457200" y="960120"/>
-            <a:ext cx="8229600" cy="3383280"/>
+            <a:ext cx="8229600" cy="3749039"/>
           </a:xfrm>
           <a:prstGeom prst="roundRect">
             <a:avLst>
@@ -14420,7 +14420,7 @@
       </p:sp>
       <p:pic>
         <p:nvPicPr>
-          <p:cNvPr id="21" name="Picture 20" descr="arch_slide.png"/>
+          <p:cNvPr id="21" name="Picture 20" descr="d01_architecture.png"/>
           <p:cNvPicPr>
             <a:picLocks noChangeAspect="1"/>
           </p:cNvPicPr>
@@ -14434,8 +14434,8 @@
         </p:blipFill>
         <p:spPr>
           <a:xfrm>
-            <a:off x="685800" y="1554480"/>
-            <a:ext cx="7772400" cy="2752795"/>
+            <a:off x="2136313" y="1600200"/>
+            <a:ext cx="4871373" cy="3017520"/>
           </a:xfrm>
           <a:prstGeom prst="rect">
             <a:avLst/>

</xml_diff>